<commit_message>
Adiciona redes sociais e site no fechamento da proposta
Rodape com site e Instagram (agencia e pessoal) no slide/pagina final,
em HTML, PDF e PPTX.

Co-Authored-By: Claude Sonnet 5 <noreply@anthropic.com>
</commit_message>
<xml_diff>
--- a/Recria/prospeccao/mercado-malheiros/apresentacao-mercado-malheiros.pptx
+++ b/Recria/prospeccao/mercado-malheiros/apresentacao-mercado-malheiros.pptx
@@ -3869,6 +3869,89 @@
                 <a:latin typeface="Lora"/>
               </a:rPr>
               <a:t>RECRIA, AGÊNCIA DE MARKETING</a:t>
+            </a:r>
+          </a:p>
+        </p:txBody>
+      </p:sp>
+      <p:sp>
+        <p:nvSpPr>
+          <p:cNvPr id="7" name="Rectangle 6"/>
+          <p:cNvSpPr/>
+          <p:nvPr/>
+        </p:nvSpPr>
+        <p:spPr>
+          <a:xfrm>
+            <a:off x="4267504" y="5349240"/>
+            <a:ext cx="3657600" cy="9525"/>
+          </a:xfrm>
+          <a:prstGeom prst="rect">
+            <a:avLst/>
+          </a:prstGeom>
+          <a:solidFill>
+            <a:srgbClr val="2A2A2A"/>
+          </a:solidFill>
+          <a:ln>
+            <a:noFill/>
+          </a:ln>
+          <a:effectLst/>
+        </p:spPr>
+        <p:style>
+          <a:lnRef idx="1">
+            <a:schemeClr val="accent1"/>
+          </a:lnRef>
+          <a:fillRef idx="3">
+            <a:schemeClr val="accent1"/>
+          </a:fillRef>
+          <a:effectRef idx="2">
+            <a:schemeClr val="accent1"/>
+          </a:effectRef>
+          <a:fontRef idx="minor">
+            <a:schemeClr val="lt1"/>
+          </a:fontRef>
+        </p:style>
+        <p:txBody>
+          <a:bodyPr rtlCol="0" anchor="ctr"/>
+          <a:lstStyle/>
+          <a:p>
+            <a:pPr algn="ctr"/>
+          </a:p>
+        </p:txBody>
+      </p:sp>
+      <p:sp>
+        <p:nvSpPr>
+          <p:cNvPr id="8" name="TextBox 7"/>
+          <p:cNvSpPr txBox="1"/>
+          <p:nvPr/>
+        </p:nvSpPr>
+        <p:spPr>
+          <a:xfrm>
+            <a:off x="640080" y="5532120"/>
+            <a:ext cx="10881360" cy="320040"/>
+          </a:xfrm>
+          <a:prstGeom prst="rect">
+            <a:avLst/>
+          </a:prstGeom>
+          <a:noFill/>
+        </p:spPr>
+        <p:txBody>
+          <a:bodyPr wrap="square" anchor="t" lIns="0" rIns="0" tIns="0" bIns="0">
+            <a:spAutoFit/>
+          </a:bodyPr>
+          <a:lstStyle/>
+          <a:p>
+            <a:pPr algn="ctr">
+              <a:lnSpc>
+                <a:spcPct val="125000"/>
+              </a:lnSpc>
+            </a:pPr>
+            <a:r>
+              <a:rPr sz="1100" b="0" i="0">
+                <a:solidFill>
+                  <a:srgbClr val="B0A89A"/>
+                </a:solidFill>
+                <a:latin typeface="Lora"/>
+              </a:rPr>
+              <a:t>www.agenciarecria.com.br   ·   @agencia.recria   ·   @amandarecria</a:t>
             </a:r>
           </a:p>
         </p:txBody>

</xml_diff>